<commit_message>
README: update signal sources, reorder demo walkthrough, add M365 agent link
</commit_message>
<xml_diff>
--- a/docs/Enterprise-Safe Copilot Orchestration for Azure Landing Zone Governance_Rebekah_Midkiff.pptx
+++ b/docs/Enterprise-Safe Copilot Orchestration for Azure Landing Zone Governance_Rebekah_Midkiff.pptx
@@ -22772,8 +22772,8 @@
         </p:nvSpPr>
         <p:spPr>
           <a:xfrm>
-            <a:off x="8685886" y="1361579"/>
-            <a:ext cx="2779776" cy="548640"/>
+            <a:off x="8685886" y="1361578"/>
+            <a:ext cx="2779776" cy="677533"/>
           </a:xfrm>
           <a:prstGeom prst="rect">
             <a:avLst/>
@@ -22830,6 +22830,42 @@
               </a:rPr>
               <a:t>• Q&amp;A</a:t>
             </a:r>
+          </a:p>
+          <a:p>
+            <a:endParaRPr lang="en-US" sz="1100" dirty="0">
+              <a:solidFill>
+                <a:srgbClr val="000000"/>
+              </a:solidFill>
+              <a:latin typeface="Segoe UI" pitchFamily="34" charset="0"/>
+              <a:cs typeface="Segoe UI" pitchFamily="34" charset="-120"/>
+            </a:endParaRPr>
+          </a:p>
+          <a:p>
+            <a:r>
+              <a:rPr lang="en-US" sz="1100" dirty="0">
+                <a:hlinkClick r:id="rId3"/>
+              </a:rPr>
+              <a:t>ALZ-</a:t>
+            </a:r>
+            <a:r>
+              <a:rPr lang="en-US" sz="1100" dirty="0" err="1">
+                <a:hlinkClick r:id="rId3"/>
+              </a:rPr>
+              <a:t>Orchastrator</a:t>
+            </a:r>
+            <a:r>
+              <a:rPr lang="en-US" sz="1100" dirty="0">
+                <a:hlinkClick r:id="rId3"/>
+              </a:rPr>
+              <a:t>-Agent</a:t>
+            </a:r>
+            <a:endParaRPr lang="en-US" sz="1100" dirty="0">
+              <a:solidFill>
+                <a:srgbClr val="000000"/>
+              </a:solidFill>
+              <a:latin typeface="Segoe UI" pitchFamily="34" charset="0"/>
+              <a:cs typeface="Segoe UI" pitchFamily="34" charset="-120"/>
+            </a:endParaRPr>
           </a:p>
         </p:txBody>
       </p:sp>

</xml_diff>